<commit_message>
Update 성경 빨리 찾기 assets, add ZIP slides and no-phone rule
Co-Authored-By: Claude Opus 4.6 (1M context) <noreply@anthropic.com>
</commit_message>
<xml_diff>
--- a/public/downloads/games/bible-speed/rules.pptx
+++ b/public/downloads/games/bible-speed/rules.pptx
@@ -38,16 +38,12 @@
   <p:notesSz cx="6858000" cy="9144000"/>
   <p:embeddedFontLst>
     <p:embeddedFont>
-      <p:font typeface="Jua" charset="1" panose="00000000000000000000"/>
+      <p:font typeface="무궁화 고딕" charset="1" panose="02020603020101020101"/>
       <p:regular r:id="rId34"/>
     </p:embeddedFont>
     <p:embeddedFont>
-      <p:font typeface="TDTD갬성명조" charset="1" panose="02000503000000000000"/>
+      <p:font typeface="무궁화 고딕 Bold" charset="1" panose="02020603020101020101"/>
       <p:regular r:id="rId35"/>
-    </p:embeddedFont>
-    <p:embeddedFont>
-      <p:font typeface="TDTD가온" charset="1" panose="02000503000000000000"/>
-      <p:regular r:id="rId36"/>
     </p:embeddedFont>
   </p:embeddedFontLst>
   <p:defaultTextStyle>
@@ -3165,8 +3161,8 @@
         </p:nvSpPr>
         <p:spPr>
           <a:xfrm rot="0">
-            <a:off x="1028700" y="3892867"/>
-            <a:ext cx="15555091" cy="2200275"/>
+            <a:off x="1028700" y="4178617"/>
+            <a:ext cx="15555091" cy="1914525"/>
           </a:xfrm>
           <a:prstGeom prst="rect">
             <a:avLst/>
@@ -3188,10 +3184,10 @@
                 <a:solidFill>
                   <a:srgbClr val="FFFAEF"/>
                 </a:solidFill>
-                <a:latin typeface="Jua"/>
-                <a:ea typeface="Jua"/>
-                <a:cs typeface="Jua"/>
-                <a:sym typeface="Jua"/>
+                <a:latin typeface="무궁화 고딕"/>
+                <a:ea typeface="무궁화 고딕"/>
+                <a:cs typeface="무궁화 고딕"/>
+                <a:sym typeface="무궁화 고딕"/>
               </a:rPr>
               <a:t>성경 빨리 찾기</a:t>
             </a:r>
@@ -3206,8 +3202,8 @@
         </p:nvSpPr>
         <p:spPr>
           <a:xfrm rot="0">
-            <a:off x="15264803" y="9812655"/>
-            <a:ext cx="2637975" cy="474345"/>
+            <a:off x="14402540" y="9822180"/>
+            <a:ext cx="3500239" cy="464820"/>
           </a:xfrm>
           <a:prstGeom prst="rect">
             <a:avLst/>
@@ -3232,10 +3228,10 @@
                 <a:solidFill>
                   <a:srgbClr val="FFFFFF"/>
                 </a:solidFill>
-                <a:latin typeface="TDTD갬성명조"/>
-                <a:ea typeface="TDTD갬성명조"/>
-                <a:cs typeface="TDTD갬성명조"/>
-                <a:sym typeface="TDTD갬성명조"/>
+                <a:latin typeface="무궁화 고딕"/>
+                <a:ea typeface="무궁화 고딕"/>
+                <a:cs typeface="무궁화 고딕"/>
+                <a:sym typeface="무궁화 고딕"/>
               </a:rPr>
               <a:t>ⓒ 2026. Sunday Play</a:t>
             </a:r>
@@ -3332,8 +3328,8 @@
         </p:nvSpPr>
         <p:spPr>
           <a:xfrm rot="0">
-            <a:off x="2717556" y="3895725"/>
-            <a:ext cx="12852888" cy="2200275"/>
+            <a:off x="2717556" y="4181475"/>
+            <a:ext cx="12852888" cy="1914525"/>
           </a:xfrm>
           <a:prstGeom prst="rect">
             <a:avLst/>
@@ -3355,10 +3351,10 @@
                 <a:solidFill>
                   <a:srgbClr val="000000"/>
                 </a:solidFill>
-                <a:latin typeface="Jua"/>
-                <a:ea typeface="Jua"/>
-                <a:cs typeface="Jua"/>
-                <a:sym typeface="Jua"/>
+                <a:latin typeface="무궁화 고딕"/>
+                <a:ea typeface="무궁화 고딕"/>
+                <a:cs typeface="무궁화 고딕"/>
+                <a:sym typeface="무궁화 고딕"/>
               </a:rPr>
               <a:t>잠언 3:5</a:t>
             </a:r>
@@ -3455,8 +3451,8 @@
         </p:nvSpPr>
         <p:spPr>
           <a:xfrm rot="0">
-            <a:off x="1436255" y="3114675"/>
-            <a:ext cx="15415490" cy="3857625"/>
+            <a:off x="1436255" y="3305175"/>
+            <a:ext cx="15415490" cy="3667125"/>
           </a:xfrm>
           <a:prstGeom prst="rect">
             <a:avLst/>
@@ -3478,10 +3474,10 @@
                 <a:solidFill>
                   <a:srgbClr val="000000"/>
                 </a:solidFill>
-                <a:latin typeface="Jua"/>
-                <a:ea typeface="Jua"/>
-                <a:cs typeface="Jua"/>
-                <a:sym typeface="Jua"/>
+                <a:latin typeface="무궁화 고딕"/>
+                <a:ea typeface="무궁화 고딕"/>
+                <a:cs typeface="무궁화 고딕"/>
+                <a:sym typeface="무궁화 고딕"/>
               </a:rPr>
               <a:t>너는 마음을 다하여</a:t>
             </a:r>
@@ -3497,10 +3493,10 @@
                 <a:solidFill>
                   <a:srgbClr val="000000"/>
                 </a:solidFill>
-                <a:latin typeface="Jua"/>
-                <a:ea typeface="Jua"/>
-                <a:cs typeface="Jua"/>
-                <a:sym typeface="Jua"/>
+                <a:latin typeface="무궁화 고딕"/>
+                <a:ea typeface="무궁화 고딕"/>
+                <a:cs typeface="무궁화 고딕"/>
+                <a:sym typeface="무궁화 고딕"/>
               </a:rPr>
               <a:t>여호와를 신뢰하고</a:t>
             </a:r>
@@ -3516,10 +3512,10 @@
                 <a:solidFill>
                   <a:srgbClr val="000000"/>
                 </a:solidFill>
-                <a:latin typeface="Jua"/>
-                <a:ea typeface="Jua"/>
-                <a:cs typeface="Jua"/>
-                <a:sym typeface="Jua"/>
+                <a:latin typeface="무궁화 고딕"/>
+                <a:ea typeface="무궁화 고딕"/>
+                <a:cs typeface="무궁화 고딕"/>
+                <a:sym typeface="무궁화 고딕"/>
               </a:rPr>
               <a:t>네 명철을 의지하지 말라</a:t>
             </a:r>
@@ -3616,8 +3612,8 @@
         </p:nvSpPr>
         <p:spPr>
           <a:xfrm rot="0">
-            <a:off x="2717556" y="3895725"/>
-            <a:ext cx="12852888" cy="2200275"/>
+            <a:off x="2717556" y="4181475"/>
+            <a:ext cx="12852888" cy="1914525"/>
           </a:xfrm>
           <a:prstGeom prst="rect">
             <a:avLst/>
@@ -3639,10 +3635,10 @@
                 <a:solidFill>
                   <a:srgbClr val="000000"/>
                 </a:solidFill>
-                <a:latin typeface="Jua"/>
-                <a:ea typeface="Jua"/>
-                <a:cs typeface="Jua"/>
-                <a:sym typeface="Jua"/>
+                <a:latin typeface="무궁화 고딕"/>
+                <a:ea typeface="무궁화 고딕"/>
+                <a:cs typeface="무궁화 고딕"/>
+                <a:sym typeface="무궁화 고딕"/>
               </a:rPr>
               <a:t>이사야 41:10</a:t>
             </a:r>
@@ -3739,8 +3735,8 @@
         </p:nvSpPr>
         <p:spPr>
           <a:xfrm rot="0">
-            <a:off x="1719972" y="2328862"/>
-            <a:ext cx="14848057" cy="5457825"/>
+            <a:off x="1719972" y="2705100"/>
+            <a:ext cx="14848057" cy="4867275"/>
           </a:xfrm>
           <a:prstGeom prst="rect">
             <a:avLst/>
@@ -3754,18 +3750,18 @@
           <a:p>
             <a:pPr algn="ctr">
               <a:lnSpc>
-                <a:spcPts val="8399"/>
+                <a:spcPts val="7680"/>
               </a:lnSpc>
             </a:pPr>
             <a:r>
-              <a:rPr lang="en-US" sz="6999">
+              <a:rPr lang="en-US" sz="6400">
                 <a:solidFill>
                   <a:srgbClr val="000000"/>
                 </a:solidFill>
-                <a:latin typeface="Jua"/>
-                <a:ea typeface="Jua"/>
-                <a:cs typeface="Jua"/>
-                <a:sym typeface="Jua"/>
+                <a:latin typeface="무궁화 고딕"/>
+                <a:ea typeface="무궁화 고딕"/>
+                <a:cs typeface="무궁화 고딕"/>
+                <a:sym typeface="무궁화 고딕"/>
               </a:rPr>
               <a:t>두려워하지 말라 내가 너와 함께 함이라</a:t>
             </a:r>
@@ -3773,18 +3769,18 @@
           <a:p>
             <a:pPr algn="ctr">
               <a:lnSpc>
-                <a:spcPts val="8399"/>
+                <a:spcPts val="7680"/>
               </a:lnSpc>
             </a:pPr>
             <a:r>
-              <a:rPr lang="en-US" sz="6999">
+              <a:rPr lang="en-US" sz="6400">
                 <a:solidFill>
                   <a:srgbClr val="000000"/>
                 </a:solidFill>
-                <a:latin typeface="Jua"/>
-                <a:ea typeface="Jua"/>
-                <a:cs typeface="Jua"/>
-                <a:sym typeface="Jua"/>
+                <a:latin typeface="무궁화 고딕"/>
+                <a:ea typeface="무궁화 고딕"/>
+                <a:cs typeface="무궁화 고딕"/>
+                <a:sym typeface="무궁화 고딕"/>
               </a:rPr>
               <a:t>놀라지 말라 나는 네 하나님이 됨이라</a:t>
             </a:r>
@@ -3792,18 +3788,18 @@
           <a:p>
             <a:pPr algn="ctr">
               <a:lnSpc>
-                <a:spcPts val="8399"/>
+                <a:spcPts val="7680"/>
               </a:lnSpc>
             </a:pPr>
             <a:r>
-              <a:rPr lang="en-US" sz="6999">
+              <a:rPr lang="en-US" sz="6400">
                 <a:solidFill>
                   <a:srgbClr val="000000"/>
                 </a:solidFill>
-                <a:latin typeface="Jua"/>
-                <a:ea typeface="Jua"/>
-                <a:cs typeface="Jua"/>
-                <a:sym typeface="Jua"/>
+                <a:latin typeface="무궁화 고딕"/>
+                <a:ea typeface="무궁화 고딕"/>
+                <a:cs typeface="무궁화 고딕"/>
+                <a:sym typeface="무궁화 고딕"/>
               </a:rPr>
               <a:t>내가 너를 굳세게 하리라</a:t>
             </a:r>
@@ -3811,18 +3807,18 @@
           <a:p>
             <a:pPr algn="ctr">
               <a:lnSpc>
-                <a:spcPts val="8399"/>
+                <a:spcPts val="7680"/>
               </a:lnSpc>
             </a:pPr>
             <a:r>
-              <a:rPr lang="en-US" sz="6999">
+              <a:rPr lang="en-US" sz="6400">
                 <a:solidFill>
                   <a:srgbClr val="000000"/>
                 </a:solidFill>
-                <a:latin typeface="Jua"/>
-                <a:ea typeface="Jua"/>
-                <a:cs typeface="Jua"/>
-                <a:sym typeface="Jua"/>
+                <a:latin typeface="무궁화 고딕"/>
+                <a:ea typeface="무궁화 고딕"/>
+                <a:cs typeface="무궁화 고딕"/>
+                <a:sym typeface="무궁화 고딕"/>
               </a:rPr>
               <a:t>참으로 너를 도와주리라</a:t>
             </a:r>
@@ -3830,18 +3826,18 @@
           <a:p>
             <a:pPr algn="ctr">
               <a:lnSpc>
-                <a:spcPts val="8399"/>
+                <a:spcPts val="7680"/>
               </a:lnSpc>
             </a:pPr>
             <a:r>
-              <a:rPr lang="en-US" sz="6999">
+              <a:rPr lang="en-US" sz="6400">
                 <a:solidFill>
                   <a:srgbClr val="000000"/>
                 </a:solidFill>
-                <a:latin typeface="Jua"/>
-                <a:ea typeface="Jua"/>
-                <a:cs typeface="Jua"/>
-                <a:sym typeface="Jua"/>
+                <a:latin typeface="무궁화 고딕"/>
+                <a:ea typeface="무궁화 고딕"/>
+                <a:cs typeface="무궁화 고딕"/>
+                <a:sym typeface="무궁화 고딕"/>
               </a:rPr>
               <a:t>참으로 나의 의로운 오른손으로 너를 붙들리라</a:t>
             </a:r>
@@ -3938,8 +3934,8 @@
         </p:nvSpPr>
         <p:spPr>
           <a:xfrm rot="0">
-            <a:off x="2717556" y="3895725"/>
-            <a:ext cx="12852888" cy="2200275"/>
+            <a:off x="2717556" y="4181475"/>
+            <a:ext cx="12852888" cy="1914525"/>
           </a:xfrm>
           <a:prstGeom prst="rect">
             <a:avLst/>
@@ -3961,10 +3957,10 @@
                 <a:solidFill>
                   <a:srgbClr val="000000"/>
                 </a:solidFill>
-                <a:latin typeface="Jua"/>
-                <a:ea typeface="Jua"/>
-                <a:cs typeface="Jua"/>
-                <a:sym typeface="Jua"/>
+                <a:latin typeface="무궁화 고딕"/>
+                <a:ea typeface="무궁화 고딕"/>
+                <a:cs typeface="무궁화 고딕"/>
+                <a:sym typeface="무궁화 고딕"/>
               </a:rPr>
               <a:t>로마서 8:28</a:t>
             </a:r>
@@ -4061,8 +4057,8 @@
         </p:nvSpPr>
         <p:spPr>
           <a:xfrm rot="0">
-            <a:off x="1491168" y="3114675"/>
-            <a:ext cx="15305664" cy="3857625"/>
+            <a:off x="1491168" y="3376613"/>
+            <a:ext cx="15305664" cy="3524250"/>
           </a:xfrm>
           <a:prstGeom prst="rect">
             <a:avLst/>
@@ -4076,18 +4072,18 @@
           <a:p>
             <a:pPr algn="ctr">
               <a:lnSpc>
-                <a:spcPts val="9600"/>
+                <a:spcPts val="9240"/>
               </a:lnSpc>
             </a:pPr>
             <a:r>
-              <a:rPr lang="en-US" sz="8000">
+              <a:rPr lang="en-US" sz="7700">
                 <a:solidFill>
                   <a:srgbClr val="000000"/>
                 </a:solidFill>
-                <a:latin typeface="Jua"/>
-                <a:ea typeface="Jua"/>
-                <a:cs typeface="Jua"/>
-                <a:sym typeface="Jua"/>
+                <a:latin typeface="무궁화 고딕"/>
+                <a:ea typeface="무궁화 고딕"/>
+                <a:cs typeface="무궁화 고딕"/>
+                <a:sym typeface="무궁화 고딕"/>
               </a:rPr>
               <a:t>우리가 알거니와 하나님을 사랑하는 자 곧 그의 뜻대로 부르심을 입은 자들에게는 모든 것이 합력하여 선을 이루느니라</a:t>
             </a:r>
@@ -4184,8 +4180,8 @@
         </p:nvSpPr>
         <p:spPr>
           <a:xfrm rot="0">
-            <a:off x="2717556" y="3895725"/>
-            <a:ext cx="12852888" cy="2200275"/>
+            <a:off x="2717556" y="4181475"/>
+            <a:ext cx="12852888" cy="1914525"/>
           </a:xfrm>
           <a:prstGeom prst="rect">
             <a:avLst/>
@@ -4207,10 +4203,10 @@
                 <a:solidFill>
                   <a:srgbClr val="000000"/>
                 </a:solidFill>
-                <a:latin typeface="Jua"/>
-                <a:ea typeface="Jua"/>
-                <a:cs typeface="Jua"/>
-                <a:sym typeface="Jua"/>
+                <a:latin typeface="무궁화 고딕"/>
+                <a:ea typeface="무궁화 고딕"/>
+                <a:cs typeface="무궁화 고딕"/>
+                <a:sym typeface="무궁화 고딕"/>
               </a:rPr>
               <a:t>예레미야 29:11</a:t>
             </a:r>
@@ -4307,8 +4303,8 @@
         </p:nvSpPr>
         <p:spPr>
           <a:xfrm rot="0">
-            <a:off x="1125082" y="2505075"/>
-            <a:ext cx="16037836" cy="5076825"/>
+            <a:off x="1125082" y="2695575"/>
+            <a:ext cx="16037836" cy="4886325"/>
           </a:xfrm>
           <a:prstGeom prst="rect">
             <a:avLst/>
@@ -4330,10 +4326,10 @@
                 <a:solidFill>
                   <a:srgbClr val="000000"/>
                 </a:solidFill>
-                <a:latin typeface="Jua"/>
-                <a:ea typeface="Jua"/>
-                <a:cs typeface="Jua"/>
-                <a:sym typeface="Jua"/>
+                <a:latin typeface="무궁화 고딕"/>
+                <a:ea typeface="무궁화 고딕"/>
+                <a:cs typeface="무궁화 고딕"/>
+                <a:sym typeface="무궁화 고딕"/>
               </a:rPr>
               <a:t>여호와의 말씀이니라</a:t>
             </a:r>
@@ -4349,10 +4345,10 @@
                 <a:solidFill>
                   <a:srgbClr val="000000"/>
                 </a:solidFill>
-                <a:latin typeface="Jua"/>
-                <a:ea typeface="Jua"/>
-                <a:cs typeface="Jua"/>
-                <a:sym typeface="Jua"/>
+                <a:latin typeface="무궁화 고딕"/>
+                <a:ea typeface="무궁화 고딕"/>
+                <a:cs typeface="무궁화 고딕"/>
+                <a:sym typeface="무궁화 고딕"/>
               </a:rPr>
               <a:t>너희를 향한 나의 생각을 내가 아나니</a:t>
             </a:r>
@@ -4368,10 +4364,10 @@
                 <a:solidFill>
                   <a:srgbClr val="000000"/>
                 </a:solidFill>
-                <a:latin typeface="Jua"/>
-                <a:ea typeface="Jua"/>
-                <a:cs typeface="Jua"/>
-                <a:sym typeface="Jua"/>
+                <a:latin typeface="무궁화 고딕"/>
+                <a:ea typeface="무궁화 고딕"/>
+                <a:cs typeface="무궁화 고딕"/>
+                <a:sym typeface="무궁화 고딕"/>
               </a:rPr>
               <a:t>평안이요 재앙이 아니니라</a:t>
             </a:r>
@@ -4387,10 +4383,10 @@
                 <a:solidFill>
                   <a:srgbClr val="000000"/>
                 </a:solidFill>
-                <a:latin typeface="Jua"/>
-                <a:ea typeface="Jua"/>
-                <a:cs typeface="Jua"/>
-                <a:sym typeface="Jua"/>
+                <a:latin typeface="무궁화 고딕"/>
+                <a:ea typeface="무궁화 고딕"/>
+                <a:cs typeface="무궁화 고딕"/>
+                <a:sym typeface="무궁화 고딕"/>
               </a:rPr>
               <a:t>너희에게 미래와 희망을 주는 것이니라</a:t>
             </a:r>
@@ -4487,8 +4483,8 @@
         </p:nvSpPr>
         <p:spPr>
           <a:xfrm rot="0">
-            <a:off x="2717556" y="3895725"/>
-            <a:ext cx="12852888" cy="2200275"/>
+            <a:off x="2717556" y="4181475"/>
+            <a:ext cx="12852888" cy="1914525"/>
           </a:xfrm>
           <a:prstGeom prst="rect">
             <a:avLst/>
@@ -4510,10 +4506,10 @@
                 <a:solidFill>
                   <a:srgbClr val="000000"/>
                 </a:solidFill>
-                <a:latin typeface="Jua"/>
-                <a:ea typeface="Jua"/>
-                <a:cs typeface="Jua"/>
-                <a:sym typeface="Jua"/>
+                <a:latin typeface="무궁화 고딕"/>
+                <a:ea typeface="무궁화 고딕"/>
+                <a:cs typeface="무궁화 고딕"/>
+                <a:sym typeface="무궁화 고딕"/>
               </a:rPr>
               <a:t>빌립보서 4:13</a:t>
             </a:r>
@@ -4610,8 +4606,8 @@
         </p:nvSpPr>
         <p:spPr>
           <a:xfrm rot="0">
-            <a:off x="2717556" y="3724275"/>
-            <a:ext cx="12852888" cy="2638425"/>
+            <a:off x="2717556" y="3914775"/>
+            <a:ext cx="12852888" cy="2447925"/>
           </a:xfrm>
           <a:prstGeom prst="rect">
             <a:avLst/>
@@ -4633,10 +4629,10 @@
                 <a:solidFill>
                   <a:srgbClr val="000000"/>
                 </a:solidFill>
-                <a:latin typeface="Jua"/>
-                <a:ea typeface="Jua"/>
-                <a:cs typeface="Jua"/>
-                <a:sym typeface="Jua"/>
+                <a:latin typeface="무궁화 고딕"/>
+                <a:ea typeface="무궁화 고딕"/>
+                <a:cs typeface="무궁화 고딕"/>
+                <a:sym typeface="무궁화 고딕"/>
               </a:rPr>
               <a:t>내게 능력 주시는 자 안에서</a:t>
             </a:r>
@@ -4652,10 +4648,10 @@
                 <a:solidFill>
                   <a:srgbClr val="000000"/>
                 </a:solidFill>
-                <a:latin typeface="Jua"/>
-                <a:ea typeface="Jua"/>
-                <a:cs typeface="Jua"/>
-                <a:sym typeface="Jua"/>
+                <a:latin typeface="무궁화 고딕"/>
+                <a:ea typeface="무궁화 고딕"/>
+                <a:cs typeface="무궁화 고딕"/>
+                <a:sym typeface="무궁화 고딕"/>
               </a:rPr>
               <a:t>내가 모든 것을 할 수 있느니라</a:t>
             </a:r>
@@ -4804,8 +4800,8 @@
         </p:nvSpPr>
         <p:spPr>
           <a:xfrm rot="0">
-            <a:off x="11392761" y="600705"/>
-            <a:ext cx="5362043" cy="1600200"/>
+            <a:off x="11392761" y="819780"/>
+            <a:ext cx="5362043" cy="1381125"/>
           </a:xfrm>
           <a:prstGeom prst="rect">
             <a:avLst/>
@@ -4827,10 +4823,10 @@
                 <a:solidFill>
                   <a:srgbClr val="FFFAEF"/>
                 </a:solidFill>
-                <a:latin typeface="Jua"/>
-                <a:ea typeface="Jua"/>
-                <a:cs typeface="Jua"/>
-                <a:sym typeface="Jua"/>
+                <a:latin typeface="무궁화 고딕"/>
+                <a:ea typeface="무궁화 고딕"/>
+                <a:cs typeface="무궁화 고딕"/>
+                <a:sym typeface="무궁화 고딕"/>
               </a:rPr>
               <a:t>규칙</a:t>
             </a:r>
@@ -4846,9 +4842,9 @@
         <p:grpSpPr>
           <a:xfrm rot="0">
             <a:off x="217650" y="223900"/>
-            <a:ext cx="10360529" cy="2056505"/>
+            <a:ext cx="10360529" cy="2052118"/>
             <a:chOff x="0" y="0"/>
-            <a:chExt cx="13814039" cy="2742007"/>
+            <a:chExt cx="13814039" cy="2736157"/>
           </a:xfrm>
         </p:grpSpPr>
         <p:sp>
@@ -4859,7 +4855,7 @@
           </p:nvSpPr>
           <p:spPr>
             <a:xfrm rot="0">
-              <a:off x="0" y="1625465"/>
+              <a:off x="0" y="1619616"/>
               <a:ext cx="13814039" cy="1116542"/>
             </a:xfrm>
             <a:prstGeom prst="rect">
@@ -4882,10 +4878,10 @@
                   <a:solidFill>
                     <a:srgbClr val="FFFAEF"/>
                   </a:solidFill>
-                  <a:latin typeface="TDTD가온"/>
-                  <a:ea typeface="TDTD가온"/>
-                  <a:cs typeface="TDTD가온"/>
-                  <a:sym typeface="TDTD가온"/>
+                  <a:latin typeface="무궁화 고딕"/>
+                  <a:ea typeface="무궁화 고딕"/>
+                  <a:cs typeface="무궁화 고딕"/>
+                  <a:sym typeface="무궁화 고딕"/>
                 </a:rPr>
                 <a:t>성경책을 준비합니다.</a:t>
               </a:r>
@@ -4900,8 +4896,8 @@
           </p:nvSpPr>
           <p:spPr>
             <a:xfrm rot="0">
-              <a:off x="0" y="-190500"/>
-              <a:ext cx="11298371" cy="1367863"/>
+              <a:off x="0" y="-66675"/>
+              <a:ext cx="11298371" cy="1238189"/>
             </a:xfrm>
             <a:prstGeom prst="rect">
               <a:avLst/>
@@ -4923,10 +4919,10 @@
                   <a:solidFill>
                     <a:srgbClr val="FFFAEF"/>
                   </a:solidFill>
-                  <a:latin typeface="Jua"/>
-                  <a:ea typeface="Jua"/>
-                  <a:cs typeface="Jua"/>
-                  <a:sym typeface="Jua"/>
+                  <a:latin typeface="무궁화 고딕 Bold"/>
+                  <a:ea typeface="무궁화 고딕 Bold"/>
+                  <a:cs typeface="무궁화 고딕 Bold"/>
+                  <a:sym typeface="무궁화 고딕 Bold"/>
                 </a:rPr>
                 <a:t>STEP 1.</a:t>
               </a:r>
@@ -4942,7 +4938,7 @@
         </p:nvGrpSpPr>
         <p:grpSpPr>
           <a:xfrm rot="0">
-            <a:off x="9144000" y="7809938"/>
+            <a:off x="9144000" y="7950306"/>
             <a:ext cx="9144000" cy="1994512"/>
             <a:chOff x="0" y="0"/>
             <a:chExt cx="12192000" cy="2659349"/>
@@ -4979,10 +4975,10 @@
                   <a:solidFill>
                     <a:srgbClr val="FFFAEF"/>
                   </a:solidFill>
-                  <a:latin typeface="TDTD가온"/>
-                  <a:ea typeface="TDTD가온"/>
-                  <a:cs typeface="TDTD가온"/>
-                  <a:sym typeface="TDTD가온"/>
+                  <a:latin typeface="무궁화 고딕"/>
+                  <a:ea typeface="무궁화 고딕"/>
+                  <a:cs typeface="무궁화 고딕"/>
+                  <a:sym typeface="무궁화 고딕"/>
                 </a:rPr>
                 <a:t>가장 많은 점수를 얻은 사람이 우승!</a:t>
               </a:r>
@@ -4997,8 +4993,8 @@
           </p:nvSpPr>
           <p:spPr>
             <a:xfrm rot="0">
-              <a:off x="0" y="-190500"/>
-              <a:ext cx="12192000" cy="1374479"/>
+              <a:off x="0" y="-57150"/>
+              <a:ext cx="12192000" cy="1241129"/>
             </a:xfrm>
             <a:prstGeom prst="rect">
               <a:avLst/>
@@ -5020,10 +5016,10 @@
                   <a:solidFill>
                     <a:srgbClr val="FFFAEF"/>
                   </a:solidFill>
-                  <a:latin typeface="Jua"/>
-                  <a:ea typeface="Jua"/>
-                  <a:cs typeface="Jua"/>
-                  <a:sym typeface="Jua"/>
+                  <a:latin typeface="무궁화 고딕 Bold"/>
+                  <a:ea typeface="무궁화 고딕 Bold"/>
+                  <a:cs typeface="무궁화 고딕 Bold"/>
+                  <a:sym typeface="무궁화 고딕 Bold"/>
                 </a:rPr>
                 <a:t>STEP 3.</a:t>
               </a:r>
@@ -5039,10 +5035,10 @@
         </p:nvGrpSpPr>
         <p:grpSpPr>
           <a:xfrm rot="0">
-            <a:off x="4862181" y="3575413"/>
-            <a:ext cx="9376340" cy="2939517"/>
+            <a:off x="4697442" y="3646427"/>
+            <a:ext cx="9376340" cy="2933470"/>
             <a:chOff x="0" y="0"/>
-            <a:chExt cx="12501787" cy="3919356"/>
+            <a:chExt cx="12501787" cy="3911293"/>
           </a:xfrm>
         </p:grpSpPr>
         <p:sp>
@@ -5053,7 +5049,7 @@
           </p:nvSpPr>
           <p:spPr>
             <a:xfrm rot="0">
-              <a:off x="0" y="1631121"/>
+              <a:off x="0" y="1623059"/>
               <a:ext cx="12501787" cy="2288235"/>
             </a:xfrm>
             <a:prstGeom prst="rect">
@@ -5076,10 +5072,10 @@
                   <a:solidFill>
                     <a:srgbClr val="FFFAEF"/>
                   </a:solidFill>
-                  <a:latin typeface="TDTD가온"/>
-                  <a:ea typeface="TDTD가온"/>
-                  <a:cs typeface="TDTD가온"/>
-                  <a:sym typeface="TDTD가온"/>
+                  <a:latin typeface="무궁화 고딕"/>
+                  <a:ea typeface="무궁화 고딕"/>
+                  <a:cs typeface="무궁화 고딕"/>
+                  <a:sym typeface="무궁화 고딕"/>
                 </a:rPr>
                 <a:t>진행자가 말한 구절을 가장 빨리 찾아</a:t>
               </a:r>
@@ -5095,10 +5091,10 @@
                   <a:solidFill>
                     <a:srgbClr val="FFFAEF"/>
                   </a:solidFill>
-                  <a:latin typeface="TDTD가온"/>
-                  <a:ea typeface="TDTD가온"/>
-                  <a:cs typeface="TDTD가온"/>
-                  <a:sym typeface="TDTD가온"/>
+                  <a:latin typeface="무궁화 고딕"/>
+                  <a:ea typeface="무궁화 고딕"/>
+                  <a:cs typeface="무궁화 고딕"/>
+                  <a:sym typeface="무궁화 고딕"/>
                 </a:rPr>
                 <a:t>암송하면 1점!</a:t>
               </a:r>
@@ -5113,8 +5109,8 @@
           </p:nvSpPr>
           <p:spPr>
             <a:xfrm rot="0">
-              <a:off x="0" y="-190500"/>
-              <a:ext cx="5178984" cy="1369906"/>
+              <a:off x="0" y="-66675"/>
+              <a:ext cx="5178984" cy="1238018"/>
             </a:xfrm>
             <a:prstGeom prst="rect">
               <a:avLst/>
@@ -5136,10 +5132,10 @@
                   <a:solidFill>
                     <a:srgbClr val="FFFAEF"/>
                   </a:solidFill>
-                  <a:latin typeface="Jua"/>
-                  <a:ea typeface="Jua"/>
-                  <a:cs typeface="Jua"/>
-                  <a:sym typeface="Jua"/>
+                  <a:latin typeface="무궁화 고딕 Bold"/>
+                  <a:ea typeface="무궁화 고딕 Bold"/>
+                  <a:cs typeface="무궁화 고딕 Bold"/>
+                  <a:sym typeface="무궁화 고딕 Bold"/>
                 </a:rPr>
                 <a:t>STEP 2.</a:t>
               </a:r>
@@ -5237,8 +5233,8 @@
         </p:nvSpPr>
         <p:spPr>
           <a:xfrm rot="0">
-            <a:off x="2717556" y="3895725"/>
-            <a:ext cx="12852888" cy="2200275"/>
+            <a:off x="2717556" y="4181475"/>
+            <a:ext cx="12852888" cy="1914525"/>
           </a:xfrm>
           <a:prstGeom prst="rect">
             <a:avLst/>
@@ -5260,10 +5256,10 @@
                 <a:solidFill>
                   <a:srgbClr val="000000"/>
                 </a:solidFill>
-                <a:latin typeface="Jua"/>
-                <a:ea typeface="Jua"/>
-                <a:cs typeface="Jua"/>
-                <a:sym typeface="Jua"/>
+                <a:latin typeface="무궁화 고딕"/>
+                <a:ea typeface="무궁화 고딕"/>
+                <a:cs typeface="무궁화 고딕"/>
+                <a:sym typeface="무궁화 고딕"/>
               </a:rPr>
               <a:t>미가 6:8</a:t>
             </a:r>
@@ -5360,8 +5356,8 @@
         </p:nvSpPr>
         <p:spPr>
           <a:xfrm rot="0">
-            <a:off x="287976" y="1895475"/>
-            <a:ext cx="17712047" cy="6296025"/>
+            <a:off x="287976" y="2252663"/>
+            <a:ext cx="17712047" cy="5772150"/>
           </a:xfrm>
           <a:prstGeom prst="rect">
             <a:avLst/>
@@ -5375,18 +5371,18 @@
           <a:p>
             <a:pPr algn="ctr">
               <a:lnSpc>
-                <a:spcPts val="9600"/>
+                <a:spcPts val="9120"/>
               </a:lnSpc>
             </a:pPr>
             <a:r>
-              <a:rPr lang="en-US" sz="8000">
+              <a:rPr lang="en-US" sz="7600">
                 <a:solidFill>
                   <a:srgbClr val="000000"/>
                 </a:solidFill>
-                <a:latin typeface="Jua"/>
-                <a:ea typeface="Jua"/>
-                <a:cs typeface="Jua"/>
-                <a:sym typeface="Jua"/>
+                <a:latin typeface="무궁화 고딕"/>
+                <a:ea typeface="무궁화 고딕"/>
+                <a:cs typeface="무궁화 고딕"/>
+                <a:sym typeface="무궁화 고딕"/>
               </a:rPr>
               <a:t>사람아 주께서 선한 것이 무엇임을</a:t>
             </a:r>
@@ -5394,18 +5390,18 @@
           <a:p>
             <a:pPr algn="ctr">
               <a:lnSpc>
-                <a:spcPts val="9600"/>
+                <a:spcPts val="9120"/>
               </a:lnSpc>
             </a:pPr>
             <a:r>
-              <a:rPr lang="en-US" sz="8000">
+              <a:rPr lang="en-US" sz="7600">
                 <a:solidFill>
                   <a:srgbClr val="000000"/>
                 </a:solidFill>
-                <a:latin typeface="Jua"/>
-                <a:ea typeface="Jua"/>
-                <a:cs typeface="Jua"/>
-                <a:sym typeface="Jua"/>
+                <a:latin typeface="무궁화 고딕"/>
+                <a:ea typeface="무궁화 고딕"/>
+                <a:cs typeface="무궁화 고딕"/>
+                <a:sym typeface="무궁화 고딕"/>
               </a:rPr>
               <a:t>네게 보이셨나니</a:t>
             </a:r>
@@ -5413,18 +5409,18 @@
           <a:p>
             <a:pPr algn="ctr">
               <a:lnSpc>
-                <a:spcPts val="9600"/>
+                <a:spcPts val="9120"/>
               </a:lnSpc>
             </a:pPr>
             <a:r>
-              <a:rPr lang="en-US" sz="8000">
+              <a:rPr lang="en-US" sz="7600">
                 <a:solidFill>
                   <a:srgbClr val="000000"/>
                 </a:solidFill>
-                <a:latin typeface="Jua"/>
-                <a:ea typeface="Jua"/>
-                <a:cs typeface="Jua"/>
-                <a:sym typeface="Jua"/>
+                <a:latin typeface="무궁화 고딕"/>
+                <a:ea typeface="무궁화 고딕"/>
+                <a:cs typeface="무궁화 고딕"/>
+                <a:sym typeface="무궁화 고딕"/>
               </a:rPr>
               <a:t>여호와께서 네게 구하시는 것은</a:t>
             </a:r>
@@ -5432,18 +5428,18 @@
           <a:p>
             <a:pPr algn="ctr">
               <a:lnSpc>
-                <a:spcPts val="9600"/>
+                <a:spcPts val="9120"/>
               </a:lnSpc>
             </a:pPr>
             <a:r>
-              <a:rPr lang="en-US" sz="8000">
+              <a:rPr lang="en-US" sz="7600">
                 <a:solidFill>
                   <a:srgbClr val="000000"/>
                 </a:solidFill>
-                <a:latin typeface="Jua"/>
-                <a:ea typeface="Jua"/>
-                <a:cs typeface="Jua"/>
-                <a:sym typeface="Jua"/>
+                <a:latin typeface="무궁화 고딕"/>
+                <a:ea typeface="무궁화 고딕"/>
+                <a:cs typeface="무궁화 고딕"/>
+                <a:sym typeface="무궁화 고딕"/>
               </a:rPr>
               <a:t>오직 정의를 행하며 인자를 사랑하며</a:t>
             </a:r>
@@ -5451,18 +5447,18 @@
           <a:p>
             <a:pPr algn="ctr">
               <a:lnSpc>
-                <a:spcPts val="9600"/>
+                <a:spcPts val="9120"/>
               </a:lnSpc>
             </a:pPr>
             <a:r>
-              <a:rPr lang="en-US" sz="8000">
+              <a:rPr lang="en-US" sz="7600">
                 <a:solidFill>
                   <a:srgbClr val="000000"/>
                 </a:solidFill>
-                <a:latin typeface="Jua"/>
-                <a:ea typeface="Jua"/>
-                <a:cs typeface="Jua"/>
-                <a:sym typeface="Jua"/>
+                <a:latin typeface="무궁화 고딕"/>
+                <a:ea typeface="무궁화 고딕"/>
+                <a:cs typeface="무궁화 고딕"/>
+                <a:sym typeface="무궁화 고딕"/>
               </a:rPr>
               <a:t>겸손하게 네 하나님과 함께 행하는 것이 아니냐</a:t>
             </a:r>
@@ -5559,8 +5555,8 @@
         </p:nvSpPr>
         <p:spPr>
           <a:xfrm rot="0">
-            <a:off x="2717556" y="3895725"/>
-            <a:ext cx="12852888" cy="2200275"/>
+            <a:off x="2717556" y="4181475"/>
+            <a:ext cx="12852888" cy="1914525"/>
           </a:xfrm>
           <a:prstGeom prst="rect">
             <a:avLst/>
@@ -5582,10 +5578,10 @@
                 <a:solidFill>
                   <a:srgbClr val="000000"/>
                 </a:solidFill>
-                <a:latin typeface="Jua"/>
-                <a:ea typeface="Jua"/>
-                <a:cs typeface="Jua"/>
-                <a:sym typeface="Jua"/>
+                <a:latin typeface="무궁화 고딕"/>
+                <a:ea typeface="무궁화 고딕"/>
+                <a:cs typeface="무궁화 고딕"/>
+                <a:sym typeface="무궁화 고딕"/>
               </a:rPr>
               <a:t>하박국 3:18</a:t>
             </a:r>
@@ -5682,8 +5678,8 @@
         </p:nvSpPr>
         <p:spPr>
           <a:xfrm rot="0">
-            <a:off x="287976" y="3724275"/>
-            <a:ext cx="17712047" cy="2638425"/>
+            <a:off x="287976" y="4029075"/>
+            <a:ext cx="17712047" cy="2219325"/>
           </a:xfrm>
           <a:prstGeom prst="rect">
             <a:avLst/>
@@ -5697,18 +5693,18 @@
           <a:p>
             <a:pPr algn="ctr">
               <a:lnSpc>
-                <a:spcPts val="9600"/>
+                <a:spcPts val="8760"/>
               </a:lnSpc>
             </a:pPr>
             <a:r>
-              <a:rPr lang="en-US" sz="8000">
+              <a:rPr lang="en-US" sz="7300">
                 <a:solidFill>
                   <a:srgbClr val="000000"/>
                 </a:solidFill>
-                <a:latin typeface="Jua"/>
-                <a:ea typeface="Jua"/>
-                <a:cs typeface="Jua"/>
-                <a:sym typeface="Jua"/>
+                <a:latin typeface="무궁화 고딕"/>
+                <a:ea typeface="무궁화 고딕"/>
+                <a:cs typeface="무궁화 고딕"/>
+                <a:sym typeface="무궁화 고딕"/>
               </a:rPr>
               <a:t>나는 여호와로 말미암아 즐거워하며</a:t>
             </a:r>
@@ -5716,18 +5712,18 @@
           <a:p>
             <a:pPr algn="ctr">
               <a:lnSpc>
-                <a:spcPts val="9600"/>
+                <a:spcPts val="8760"/>
               </a:lnSpc>
             </a:pPr>
             <a:r>
-              <a:rPr lang="en-US" sz="8000">
+              <a:rPr lang="en-US" sz="7300">
                 <a:solidFill>
                   <a:srgbClr val="000000"/>
                 </a:solidFill>
-                <a:latin typeface="Jua"/>
-                <a:ea typeface="Jua"/>
-                <a:cs typeface="Jua"/>
-                <a:sym typeface="Jua"/>
+                <a:latin typeface="무궁화 고딕"/>
+                <a:ea typeface="무궁화 고딕"/>
+                <a:cs typeface="무궁화 고딕"/>
+                <a:sym typeface="무궁화 고딕"/>
               </a:rPr>
               <a:t>나의 구원의 하나님으로 말미암아 기뻐하리로다</a:t>
             </a:r>
@@ -5824,8 +5820,8 @@
         </p:nvSpPr>
         <p:spPr>
           <a:xfrm rot="0">
-            <a:off x="2717556" y="3895725"/>
-            <a:ext cx="12852888" cy="2200275"/>
+            <a:off x="2717556" y="4181475"/>
+            <a:ext cx="12852888" cy="1914525"/>
           </a:xfrm>
           <a:prstGeom prst="rect">
             <a:avLst/>
@@ -5847,10 +5843,10 @@
                 <a:solidFill>
                   <a:srgbClr val="000000"/>
                 </a:solidFill>
-                <a:latin typeface="Jua"/>
-                <a:ea typeface="Jua"/>
-                <a:cs typeface="Jua"/>
-                <a:sym typeface="Jua"/>
+                <a:latin typeface="무궁화 고딕"/>
+                <a:ea typeface="무궁화 고딕"/>
+                <a:cs typeface="무궁화 고딕"/>
+                <a:sym typeface="무궁화 고딕"/>
               </a:rPr>
               <a:t>골로새서 3:23</a:t>
             </a:r>
@@ -5947,8 +5943,8 @@
         </p:nvSpPr>
         <p:spPr>
           <a:xfrm rot="0">
-            <a:off x="287976" y="3724275"/>
-            <a:ext cx="17712047" cy="2638425"/>
+            <a:off x="287976" y="3914775"/>
+            <a:ext cx="17712047" cy="2447925"/>
           </a:xfrm>
           <a:prstGeom prst="rect">
             <a:avLst/>
@@ -5970,10 +5966,10 @@
                 <a:solidFill>
                   <a:srgbClr val="000000"/>
                 </a:solidFill>
-                <a:latin typeface="Jua"/>
-                <a:ea typeface="Jua"/>
-                <a:cs typeface="Jua"/>
-                <a:sym typeface="Jua"/>
+                <a:latin typeface="무궁화 고딕"/>
+                <a:ea typeface="무궁화 고딕"/>
+                <a:cs typeface="무궁화 고딕"/>
+                <a:sym typeface="무궁화 고딕"/>
               </a:rPr>
               <a:t>무슨 일을 하든지 마음을 다하여</a:t>
             </a:r>
@@ -5989,10 +5985,10 @@
                 <a:solidFill>
                   <a:srgbClr val="000000"/>
                 </a:solidFill>
-                <a:latin typeface="Jua"/>
-                <a:ea typeface="Jua"/>
-                <a:cs typeface="Jua"/>
-                <a:sym typeface="Jua"/>
+                <a:latin typeface="무궁화 고딕"/>
+                <a:ea typeface="무궁화 고딕"/>
+                <a:cs typeface="무궁화 고딕"/>
+                <a:sym typeface="무궁화 고딕"/>
               </a:rPr>
               <a:t>주께 하듯 하고 사람에게 하듯 하지 말라</a:t>
             </a:r>
@@ -6089,8 +6085,8 @@
         </p:nvSpPr>
         <p:spPr>
           <a:xfrm rot="0">
-            <a:off x="2717556" y="3895725"/>
-            <a:ext cx="12852888" cy="2200275"/>
+            <a:off x="2717556" y="4181475"/>
+            <a:ext cx="12852888" cy="1914525"/>
           </a:xfrm>
           <a:prstGeom prst="rect">
             <a:avLst/>
@@ -6112,10 +6108,10 @@
                 <a:solidFill>
                   <a:srgbClr val="000000"/>
                 </a:solidFill>
-                <a:latin typeface="Jua"/>
-                <a:ea typeface="Jua"/>
-                <a:cs typeface="Jua"/>
-                <a:sym typeface="Jua"/>
+                <a:latin typeface="무궁화 고딕"/>
+                <a:ea typeface="무궁화 고딕"/>
+                <a:cs typeface="무궁화 고딕"/>
+                <a:sym typeface="무궁화 고딕"/>
               </a:rPr>
               <a:t>베드로전서 5:7</a:t>
             </a:r>
@@ -6212,8 +6208,8 @@
         </p:nvSpPr>
         <p:spPr>
           <a:xfrm rot="0">
-            <a:off x="287976" y="3724275"/>
-            <a:ext cx="17712047" cy="2638425"/>
+            <a:off x="287976" y="3914775"/>
+            <a:ext cx="17712047" cy="2447925"/>
           </a:xfrm>
           <a:prstGeom prst="rect">
             <a:avLst/>
@@ -6235,10 +6231,10 @@
                 <a:solidFill>
                   <a:srgbClr val="000000"/>
                 </a:solidFill>
-                <a:latin typeface="Jua"/>
-                <a:ea typeface="Jua"/>
-                <a:cs typeface="Jua"/>
-                <a:sym typeface="Jua"/>
+                <a:latin typeface="무궁화 고딕"/>
+                <a:ea typeface="무궁화 고딕"/>
+                <a:cs typeface="무궁화 고딕"/>
+                <a:sym typeface="무궁화 고딕"/>
               </a:rPr>
               <a:t>너희 염려를 다 주께 맡기라</a:t>
             </a:r>
@@ -6254,10 +6250,10 @@
                 <a:solidFill>
                   <a:srgbClr val="000000"/>
                 </a:solidFill>
-                <a:latin typeface="Jua"/>
-                <a:ea typeface="Jua"/>
-                <a:cs typeface="Jua"/>
-                <a:sym typeface="Jua"/>
+                <a:latin typeface="무궁화 고딕"/>
+                <a:ea typeface="무궁화 고딕"/>
+                <a:cs typeface="무궁화 고딕"/>
+                <a:sym typeface="무궁화 고딕"/>
               </a:rPr>
               <a:t>이는 그가 너희를 돌보심이라</a:t>
             </a:r>
@@ -6329,8 +6325,8 @@
         </p:nvSpPr>
         <p:spPr>
           <a:xfrm rot="0">
-            <a:off x="4421807" y="3895725"/>
-            <a:ext cx="9444385" cy="2200275"/>
+            <a:off x="4421807" y="4181475"/>
+            <a:ext cx="9444385" cy="1914525"/>
           </a:xfrm>
           <a:prstGeom prst="rect">
             <a:avLst/>
@@ -6352,10 +6348,10 @@
                 <a:solidFill>
                   <a:srgbClr val="000000"/>
                 </a:solidFill>
-                <a:latin typeface="Jua"/>
-                <a:ea typeface="Jua"/>
-                <a:cs typeface="Jua"/>
-                <a:sym typeface="Jua"/>
+                <a:latin typeface="무궁화 고딕"/>
+                <a:ea typeface="무궁화 고딕"/>
+                <a:cs typeface="무궁화 고딕"/>
+                <a:sym typeface="무궁화 고딕"/>
               </a:rPr>
               <a:t>감사합니다!</a:t>
             </a:r>
@@ -6502,8 +6498,8 @@
         </p:nvSpPr>
         <p:spPr>
           <a:xfrm rot="0">
-            <a:off x="1028700" y="3892867"/>
-            <a:ext cx="15555091" cy="2200275"/>
+            <a:off x="1028700" y="4178617"/>
+            <a:ext cx="15555091" cy="1914525"/>
           </a:xfrm>
           <a:prstGeom prst="rect">
             <a:avLst/>
@@ -6525,10 +6521,10 @@
                 <a:solidFill>
                   <a:srgbClr val="FFFAEF"/>
                 </a:solidFill>
-                <a:latin typeface="Jua"/>
-                <a:ea typeface="Jua"/>
-                <a:cs typeface="Jua"/>
-                <a:sym typeface="Jua"/>
+                <a:latin typeface="무궁화 고딕"/>
+                <a:ea typeface="무궁화 고딕"/>
+                <a:cs typeface="무궁화 고딕"/>
+                <a:sym typeface="무궁화 고딕"/>
               </a:rPr>
               <a:t>성경 빨리 찾기</a:t>
             </a:r>
@@ -6543,8 +6539,8 @@
         </p:nvSpPr>
         <p:spPr>
           <a:xfrm rot="0">
-            <a:off x="15264803" y="9812655"/>
-            <a:ext cx="2637975" cy="474345"/>
+            <a:off x="14402540" y="9822180"/>
+            <a:ext cx="3500239" cy="464820"/>
           </a:xfrm>
           <a:prstGeom prst="rect">
             <a:avLst/>
@@ -6569,10 +6565,10 @@
                 <a:solidFill>
                   <a:srgbClr val="FFFFFF"/>
                 </a:solidFill>
-                <a:latin typeface="TDTD갬성명조"/>
-                <a:ea typeface="TDTD갬성명조"/>
-                <a:cs typeface="TDTD갬성명조"/>
-                <a:sym typeface="TDTD갬성명조"/>
+                <a:latin typeface="무궁화 고딕"/>
+                <a:ea typeface="무궁화 고딕"/>
+                <a:cs typeface="무궁화 고딕"/>
+                <a:sym typeface="무궁화 고딕"/>
               </a:rPr>
               <a:t>ⓒ 2026. Sunday Play</a:t>
             </a:r>
@@ -6669,8 +6665,8 @@
         </p:nvSpPr>
         <p:spPr>
           <a:xfrm rot="0">
-            <a:off x="2717556" y="3895725"/>
-            <a:ext cx="12852888" cy="2200275"/>
+            <a:off x="2717556" y="4181475"/>
+            <a:ext cx="12852888" cy="1914525"/>
           </a:xfrm>
           <a:prstGeom prst="rect">
             <a:avLst/>
@@ -6692,10 +6688,10 @@
                 <a:solidFill>
                   <a:srgbClr val="000000"/>
                 </a:solidFill>
-                <a:latin typeface="Jua"/>
-                <a:ea typeface="Jua"/>
-                <a:cs typeface="Jua"/>
-                <a:sym typeface="Jua"/>
+                <a:latin typeface="무궁화 고딕"/>
+                <a:ea typeface="무궁화 고딕"/>
+                <a:cs typeface="무궁화 고딕"/>
+                <a:sym typeface="무궁화 고딕"/>
               </a:rPr>
               <a:t>창세기 1:1</a:t>
             </a:r>
@@ -6792,8 +6788,8 @@
         </p:nvSpPr>
         <p:spPr>
           <a:xfrm rot="0">
-            <a:off x="2717556" y="3724275"/>
-            <a:ext cx="12852888" cy="2638425"/>
+            <a:off x="2717556" y="3914775"/>
+            <a:ext cx="12852888" cy="2447925"/>
           </a:xfrm>
           <a:prstGeom prst="rect">
             <a:avLst/>
@@ -6815,10 +6811,10 @@
                 <a:solidFill>
                   <a:srgbClr val="000000"/>
                 </a:solidFill>
-                <a:latin typeface="Jua"/>
-                <a:ea typeface="Jua"/>
-                <a:cs typeface="Jua"/>
-                <a:sym typeface="Jua"/>
+                <a:latin typeface="무궁화 고딕"/>
+                <a:ea typeface="무궁화 고딕"/>
+                <a:cs typeface="무궁화 고딕"/>
+                <a:sym typeface="무궁화 고딕"/>
               </a:rPr>
               <a:t>태초에 하나님이</a:t>
             </a:r>
@@ -6834,10 +6830,10 @@
                 <a:solidFill>
                   <a:srgbClr val="000000"/>
                 </a:solidFill>
-                <a:latin typeface="Jua"/>
-                <a:ea typeface="Jua"/>
-                <a:cs typeface="Jua"/>
-                <a:sym typeface="Jua"/>
+                <a:latin typeface="무궁화 고딕"/>
+                <a:ea typeface="무궁화 고딕"/>
+                <a:cs typeface="무궁화 고딕"/>
+                <a:sym typeface="무궁화 고딕"/>
               </a:rPr>
               <a:t>천지를 창조하시니라</a:t>
             </a:r>
@@ -6934,8 +6930,8 @@
         </p:nvSpPr>
         <p:spPr>
           <a:xfrm rot="0">
-            <a:off x="2717556" y="3895725"/>
-            <a:ext cx="12852888" cy="2200275"/>
+            <a:off x="2717556" y="4181475"/>
+            <a:ext cx="12852888" cy="1914525"/>
           </a:xfrm>
           <a:prstGeom prst="rect">
             <a:avLst/>
@@ -6957,10 +6953,10 @@
                 <a:solidFill>
                   <a:srgbClr val="000000"/>
                 </a:solidFill>
-                <a:latin typeface="Jua"/>
-                <a:ea typeface="Jua"/>
-                <a:cs typeface="Jua"/>
-                <a:sym typeface="Jua"/>
+                <a:latin typeface="무궁화 고딕"/>
+                <a:ea typeface="무궁화 고딕"/>
+                <a:cs typeface="무궁화 고딕"/>
+                <a:sym typeface="무궁화 고딕"/>
               </a:rPr>
               <a:t>요한복음 3:16</a:t>
             </a:r>
@@ -7057,8 +7053,8 @@
         </p:nvSpPr>
         <p:spPr>
           <a:xfrm rot="0">
-            <a:off x="1674211" y="2505075"/>
-            <a:ext cx="14939578" cy="5076825"/>
+            <a:off x="1674211" y="2695575"/>
+            <a:ext cx="14939578" cy="4886325"/>
           </a:xfrm>
           <a:prstGeom prst="rect">
             <a:avLst/>
@@ -7080,10 +7076,10 @@
                 <a:solidFill>
                   <a:srgbClr val="000000"/>
                 </a:solidFill>
-                <a:latin typeface="Jua"/>
-                <a:ea typeface="Jua"/>
-                <a:cs typeface="Jua"/>
-                <a:sym typeface="Jua"/>
+                <a:latin typeface="무궁화 고딕"/>
+                <a:ea typeface="무궁화 고딕"/>
+                <a:cs typeface="무궁화 고딕"/>
+                <a:sym typeface="무궁화 고딕"/>
               </a:rPr>
               <a:t>하나님이 세상을 이처럼 사랑하사</a:t>
             </a:r>
@@ -7099,10 +7095,10 @@
                 <a:solidFill>
                   <a:srgbClr val="000000"/>
                 </a:solidFill>
-                <a:latin typeface="Jua"/>
-                <a:ea typeface="Jua"/>
-                <a:cs typeface="Jua"/>
-                <a:sym typeface="Jua"/>
+                <a:latin typeface="무궁화 고딕"/>
+                <a:ea typeface="무궁화 고딕"/>
+                <a:cs typeface="무궁화 고딕"/>
+                <a:sym typeface="무궁화 고딕"/>
               </a:rPr>
               <a:t>독생자를 주셨으니</a:t>
             </a:r>
@@ -7118,10 +7114,10 @@
                 <a:solidFill>
                   <a:srgbClr val="000000"/>
                 </a:solidFill>
-                <a:latin typeface="Jua"/>
-                <a:ea typeface="Jua"/>
-                <a:cs typeface="Jua"/>
-                <a:sym typeface="Jua"/>
+                <a:latin typeface="무궁화 고딕"/>
+                <a:ea typeface="무궁화 고딕"/>
+                <a:cs typeface="무궁화 고딕"/>
+                <a:sym typeface="무궁화 고딕"/>
               </a:rPr>
               <a:t>이는 그를 믿는 자마다 멸망하지 않고</a:t>
             </a:r>
@@ -7137,10 +7133,10 @@
                 <a:solidFill>
                   <a:srgbClr val="000000"/>
                 </a:solidFill>
-                <a:latin typeface="Jua"/>
-                <a:ea typeface="Jua"/>
-                <a:cs typeface="Jua"/>
-                <a:sym typeface="Jua"/>
+                <a:latin typeface="무궁화 고딕"/>
+                <a:ea typeface="무궁화 고딕"/>
+                <a:cs typeface="무궁화 고딕"/>
+                <a:sym typeface="무궁화 고딕"/>
               </a:rPr>
               <a:t>영생을 얻게 하려 하심이라</a:t>
             </a:r>
@@ -7237,8 +7233,8 @@
         </p:nvSpPr>
         <p:spPr>
           <a:xfrm rot="0">
-            <a:off x="2717556" y="3895725"/>
-            <a:ext cx="12852888" cy="2200275"/>
+            <a:off x="2717556" y="4181475"/>
+            <a:ext cx="12852888" cy="1914525"/>
           </a:xfrm>
           <a:prstGeom prst="rect">
             <a:avLst/>
@@ -7260,10 +7256,10 @@
                 <a:solidFill>
                   <a:srgbClr val="000000"/>
                 </a:solidFill>
-                <a:latin typeface="Jua"/>
-                <a:ea typeface="Jua"/>
-                <a:cs typeface="Jua"/>
-                <a:sym typeface="Jua"/>
+                <a:latin typeface="무궁화 고딕"/>
+                <a:ea typeface="무궁화 고딕"/>
+                <a:cs typeface="무궁화 고딕"/>
+                <a:sym typeface="무궁화 고딕"/>
               </a:rPr>
               <a:t>시편 23:1</a:t>
             </a:r>
@@ -7360,8 +7356,8 @@
         </p:nvSpPr>
         <p:spPr>
           <a:xfrm rot="0">
-            <a:off x="1582689" y="3714041"/>
-            <a:ext cx="15122621" cy="2638425"/>
+            <a:off x="1582689" y="3904541"/>
+            <a:ext cx="15122621" cy="2447925"/>
           </a:xfrm>
           <a:prstGeom prst="rect">
             <a:avLst/>
@@ -7383,10 +7379,10 @@
                 <a:solidFill>
                   <a:srgbClr val="000000"/>
                 </a:solidFill>
-                <a:latin typeface="Jua"/>
-                <a:ea typeface="Jua"/>
-                <a:cs typeface="Jua"/>
-                <a:sym typeface="Jua"/>
+                <a:latin typeface="무궁화 고딕"/>
+                <a:ea typeface="무궁화 고딕"/>
+                <a:cs typeface="무궁화 고딕"/>
+                <a:sym typeface="무궁화 고딕"/>
               </a:rPr>
               <a:t>여호와는 나의 목자시니</a:t>
             </a:r>
@@ -7402,10 +7398,10 @@
                 <a:solidFill>
                   <a:srgbClr val="000000"/>
                 </a:solidFill>
-                <a:latin typeface="Jua"/>
-                <a:ea typeface="Jua"/>
-                <a:cs typeface="Jua"/>
-                <a:sym typeface="Jua"/>
+                <a:latin typeface="무궁화 고딕"/>
+                <a:ea typeface="무궁화 고딕"/>
+                <a:cs typeface="무궁화 고딕"/>
+                <a:sym typeface="무궁화 고딕"/>
               </a:rPr>
               <a:t>내게 부족함이 없으리로다</a:t>
             </a:r>

</xml_diff>